<commit_message>
Fix: fix pptx about pending
</commit_message>
<xml_diff>
--- a/qspinlock.pptx
+++ b/qspinlock.pptx
@@ -208,7 +208,7 @@
   <p:extLst>
     <p:ext uri="{EFAFB233-063F-42B5-8137-9DF3F51BA10A}">
       <p15:sldGuideLst xmlns:p15="http://schemas.microsoft.com/office/powerpoint/2012/main">
-        <p15:guide id="1" orient="horz" pos="2071" userDrawn="1">
+        <p15:guide id="1" orient="horz" pos="2110" userDrawn="1">
           <p15:clr>
             <a:srgbClr val="A4A3A4"/>
           </p15:clr>
@@ -3402,7 +3402,7 @@
         <a:spcBef>
           <a:spcPts val="1000"/>
         </a:spcBef>
-        <a:buFont typeface="Arial" panose="02080604020202020204" pitchFamily="34" charset="0"/>
+        <a:buFont typeface="Arial" panose="020B0604020202020204" pitchFamily="34" charset="0"/>
         <a:buChar char="•"/>
         <a:defRPr sz="2400" kern="1200">
           <a:solidFill>
@@ -3420,7 +3420,7 @@
         <a:spcBef>
           <a:spcPts val="500"/>
         </a:spcBef>
-        <a:buFont typeface="Arial" panose="02080604020202020204" pitchFamily="34" charset="0"/>
+        <a:buFont typeface="Arial" panose="020B0604020202020204" pitchFamily="34" charset="0"/>
         <a:buChar char="•"/>
         <a:defRPr sz="2000" kern="1200">
           <a:solidFill>
@@ -3438,7 +3438,7 @@
         <a:spcBef>
           <a:spcPts val="500"/>
         </a:spcBef>
-        <a:buFont typeface="Arial" panose="02080604020202020204" pitchFamily="34" charset="0"/>
+        <a:buFont typeface="Arial" panose="020B0604020202020204" pitchFamily="34" charset="0"/>
         <a:buChar char="•"/>
         <a:defRPr sz="1800" kern="1200">
           <a:solidFill>
@@ -3456,7 +3456,7 @@
         <a:spcBef>
           <a:spcPts val="500"/>
         </a:spcBef>
-        <a:buFont typeface="Arial" panose="02080604020202020204" pitchFamily="34" charset="0"/>
+        <a:buFont typeface="Arial" panose="020B0604020202020204" pitchFamily="34" charset="0"/>
         <a:buChar char="•"/>
         <a:defRPr sz="1800" kern="1200">
           <a:solidFill>
@@ -3474,7 +3474,7 @@
         <a:spcBef>
           <a:spcPts val="500"/>
         </a:spcBef>
-        <a:buFont typeface="Arial" panose="02080604020202020204" pitchFamily="34" charset="0"/>
+        <a:buFont typeface="Arial" panose="020B0604020202020204" pitchFamily="34" charset="0"/>
         <a:buChar char="•"/>
         <a:defRPr sz="1800" kern="1200">
           <a:solidFill>
@@ -3492,7 +3492,7 @@
         <a:spcBef>
           <a:spcPts val="500"/>
         </a:spcBef>
-        <a:buFont typeface="Arial" panose="02080604020202020204" pitchFamily="34" charset="0"/>
+        <a:buFont typeface="Arial" panose="020B0604020202020204" pitchFamily="34" charset="0"/>
         <a:buChar char="•"/>
         <a:defRPr sz="1800" kern="1200">
           <a:solidFill>
@@ -3510,7 +3510,7 @@
         <a:spcBef>
           <a:spcPts val="500"/>
         </a:spcBef>
-        <a:buFont typeface="Arial" panose="02080604020202020204" pitchFamily="34" charset="0"/>
+        <a:buFont typeface="Arial" panose="020B0604020202020204" pitchFamily="34" charset="0"/>
         <a:buChar char="•"/>
         <a:defRPr sz="1800" kern="1200">
           <a:solidFill>
@@ -3528,7 +3528,7 @@
         <a:spcBef>
           <a:spcPts val="500"/>
         </a:spcBef>
-        <a:buFont typeface="Arial" panose="02080604020202020204" pitchFamily="34" charset="0"/>
+        <a:buFont typeface="Arial" panose="020B0604020202020204" pitchFamily="34" charset="0"/>
         <a:buChar char="•"/>
         <a:defRPr sz="1800" kern="1200">
           <a:solidFill>
@@ -3546,7 +3546,7 @@
         <a:spcBef>
           <a:spcPts val="500"/>
         </a:spcBef>
-        <a:buFont typeface="Arial" panose="02080604020202020204" pitchFamily="34" charset="0"/>
+        <a:buFont typeface="Arial" panose="020B0604020202020204" pitchFamily="34" charset="0"/>
         <a:buChar char="•"/>
         <a:defRPr sz="1800" kern="1200">
           <a:solidFill>
@@ -3679,7 +3679,7 @@
         </p:nvSpPr>
         <p:spPr>
           <a:xfrm>
-            <a:off x="2175510" y="1115060"/>
+            <a:off x="3367405" y="1259205"/>
             <a:ext cx="6127115" cy="1325880"/>
           </a:xfrm>
         </p:spPr>
@@ -4523,8 +4523,8 @@
               <a:tblGrid>
                 <a:gridCol w="4558030"/>
                 <a:gridCol w="638175"/>
-                <a:gridCol w="1972310"/>
-                <a:gridCol w="628650"/>
+                <a:gridCol w="2298700"/>
+                <a:gridCol w="302260"/>
                 <a:gridCol w="2543810"/>
               </a:tblGrid>
               <a:tr h="1188720">
@@ -4673,7 +4673,7 @@
                           </a:solidFill>
                           <a:sym typeface="+mn-ea"/>
                         </a:rPr>
-                        <a:t>pending</a:t>
+                        <a:t>p</a:t>
                       </a:r>
                       <a:endParaRPr lang="en-US" sz="1800">
                         <a:solidFill>
@@ -7403,7 +7403,7 @@
         </p:nvSpPr>
         <p:spPr>
           <a:xfrm>
-            <a:off x="125730" y="-321945"/>
+            <a:off x="125730" y="189230"/>
             <a:ext cx="4064000" cy="460375"/>
           </a:xfrm>
           <a:prstGeom prst="rect">

</xml_diff>